<commit_message>
Adds support for max_iterations timeout
</commit_message>
<xml_diff>
--- a/ToxPipe API Guide.pptx
+++ b/ToxPipe API Guide.pptx
@@ -113,6 +113,11 @@
       </a:defRPr>
     </a:lvl9pPr>
   </p:defaultTextStyle>
+  <p:extLst>
+    <p:ext uri="{EFAFB233-063F-42B5-8137-9DF3F51BA10A}">
+      <p15:sldGuideLst xmlns:p15="http://schemas.microsoft.com/office/powerpoint/2012/main"/>
+    </p:ext>
+  </p:extLst>
 </p:presentation>
 </file>
 
@@ -4454,8 +4459,13 @@
             </a:r>
             <a:r>
               <a:rPr lang="en-US" sz="1400" dirty="0"/>
-              <a:t> – The maximum number of agentic steps (“thoughts”) the agent may take. Currently unsupported, will be added in a later update.</a:t>
-            </a:r>
+              <a:t> – The maximum number of agentic steps (“thoughts”) the agent may take. If an agent exceeds this number of steps, it will return with </a:t>
+            </a:r>
+            <a:r>
+              <a:rPr lang="en-US" sz="1400"/>
+              <a:t>an error.</a:t>
+            </a:r>
+            <a:endParaRPr lang="en-US" sz="1400" dirty="0"/>
           </a:p>
           <a:p>
             <a:pPr lvl="2">

</xml_diff>

<commit_message>
Adds step timeout to agent
</commit_message>
<xml_diff>
--- a/ToxPipe API Guide.pptx
+++ b/ToxPipe API Guide.pptx
@@ -268,7 +268,7 @@
           <a:p>
             <a:fld id="{2887AE02-B111-4481-B2BD-B82CAADB2540}" type="datetimeFigureOut">
               <a:rPr lang="en-US" smtClean="0"/>
-              <a:t>12/4/2024</a:t>
+              <a:t>12/5/2024</a:t>
             </a:fld>
             <a:endParaRPr lang="en-US"/>
           </a:p>
@@ -466,7 +466,7 @@
           <a:p>
             <a:fld id="{2887AE02-B111-4481-B2BD-B82CAADB2540}" type="datetimeFigureOut">
               <a:rPr lang="en-US" smtClean="0"/>
-              <a:t>12/4/2024</a:t>
+              <a:t>12/5/2024</a:t>
             </a:fld>
             <a:endParaRPr lang="en-US"/>
           </a:p>
@@ -674,7 +674,7 @@
           <a:p>
             <a:fld id="{2887AE02-B111-4481-B2BD-B82CAADB2540}" type="datetimeFigureOut">
               <a:rPr lang="en-US" smtClean="0"/>
-              <a:t>12/4/2024</a:t>
+              <a:t>12/5/2024</a:t>
             </a:fld>
             <a:endParaRPr lang="en-US"/>
           </a:p>
@@ -872,7 +872,7 @@
           <a:p>
             <a:fld id="{2887AE02-B111-4481-B2BD-B82CAADB2540}" type="datetimeFigureOut">
               <a:rPr lang="en-US" smtClean="0"/>
-              <a:t>12/4/2024</a:t>
+              <a:t>12/5/2024</a:t>
             </a:fld>
             <a:endParaRPr lang="en-US"/>
           </a:p>
@@ -1147,7 +1147,7 @@
           <a:p>
             <a:fld id="{2887AE02-B111-4481-B2BD-B82CAADB2540}" type="datetimeFigureOut">
               <a:rPr lang="en-US" smtClean="0"/>
-              <a:t>12/4/2024</a:t>
+              <a:t>12/5/2024</a:t>
             </a:fld>
             <a:endParaRPr lang="en-US"/>
           </a:p>
@@ -1412,7 +1412,7 @@
           <a:p>
             <a:fld id="{2887AE02-B111-4481-B2BD-B82CAADB2540}" type="datetimeFigureOut">
               <a:rPr lang="en-US" smtClean="0"/>
-              <a:t>12/4/2024</a:t>
+              <a:t>12/5/2024</a:t>
             </a:fld>
             <a:endParaRPr lang="en-US"/>
           </a:p>
@@ -1824,7 +1824,7 @@
           <a:p>
             <a:fld id="{2887AE02-B111-4481-B2BD-B82CAADB2540}" type="datetimeFigureOut">
               <a:rPr lang="en-US" smtClean="0"/>
-              <a:t>12/4/2024</a:t>
+              <a:t>12/5/2024</a:t>
             </a:fld>
             <a:endParaRPr lang="en-US"/>
           </a:p>
@@ -1965,7 +1965,7 @@
           <a:p>
             <a:fld id="{2887AE02-B111-4481-B2BD-B82CAADB2540}" type="datetimeFigureOut">
               <a:rPr lang="en-US" smtClean="0"/>
-              <a:t>12/4/2024</a:t>
+              <a:t>12/5/2024</a:t>
             </a:fld>
             <a:endParaRPr lang="en-US"/>
           </a:p>
@@ -2078,7 +2078,7 @@
           <a:p>
             <a:fld id="{2887AE02-B111-4481-B2BD-B82CAADB2540}" type="datetimeFigureOut">
               <a:rPr lang="en-US" smtClean="0"/>
-              <a:t>12/4/2024</a:t>
+              <a:t>12/5/2024</a:t>
             </a:fld>
             <a:endParaRPr lang="en-US"/>
           </a:p>
@@ -2389,7 +2389,7 @@
           <a:p>
             <a:fld id="{2887AE02-B111-4481-B2BD-B82CAADB2540}" type="datetimeFigureOut">
               <a:rPr lang="en-US" smtClean="0"/>
-              <a:t>12/4/2024</a:t>
+              <a:t>12/5/2024</a:t>
             </a:fld>
             <a:endParaRPr lang="en-US"/>
           </a:p>
@@ -2677,7 +2677,7 @@
           <a:p>
             <a:fld id="{2887AE02-B111-4481-B2BD-B82CAADB2540}" type="datetimeFigureOut">
               <a:rPr lang="en-US" smtClean="0"/>
-              <a:t>12/4/2024</a:t>
+              <a:t>12/5/2024</a:t>
             </a:fld>
             <a:endParaRPr lang="en-US"/>
           </a:p>
@@ -2918,7 +2918,7 @@
           <a:p>
             <a:fld id="{2887AE02-B111-4481-B2BD-B82CAADB2540}" type="datetimeFigureOut">
               <a:rPr lang="en-US" smtClean="0"/>
-              <a:t>12/4/2024</a:t>
+              <a:t>12/5/2024</a:t>
             </a:fld>
             <a:endParaRPr lang="en-US"/>
           </a:p>
@@ -3390,7 +3390,7 @@
           <a:p>
             <a:r>
               <a:rPr lang="en-US" dirty="0"/>
-              <a:t>Last Updated: Dec. 4, 2024</a:t>
+              <a:t>Last Updated: Dec. 5, 2024</a:t>
             </a:r>
           </a:p>
         </p:txBody>
@@ -4322,7 +4322,7 @@
         </p:spPr>
         <p:txBody>
           <a:bodyPr>
-            <a:normAutofit fontScale="92500" lnSpcReduction="10000"/>
+            <a:normAutofit fontScale="92500" lnSpcReduction="20000"/>
           </a:bodyPr>
           <a:lstStyle/>
           <a:p>
@@ -4459,13 +4459,25 @@
             </a:r>
             <a:r>
               <a:rPr lang="en-US" sz="1400" dirty="0"/>
-              <a:t> – The maximum number of agentic steps (“thoughts”) the agent may take. If an agent exceeds this number of steps, it will return with </a:t>
-            </a:r>
-            <a:r>
-              <a:rPr lang="en-US" sz="1400"/>
-              <a:t>an error.</a:t>
-            </a:r>
-            <a:endParaRPr lang="en-US" sz="1400" dirty="0"/>
+              <a:t> – The maximum number of agentic steps (“thoughts”) the agent may take. If an agent exceeds this number of steps, it will return with an error.</a:t>
+            </a:r>
+          </a:p>
+          <a:p>
+            <a:pPr lvl="2">
+              <a:tabLst>
+                <a:tab pos="5257800" algn="l"/>
+              </a:tabLst>
+            </a:pPr>
+            <a:r>
+              <a:rPr lang="en-US" sz="1400" b="1" dirty="0" err="1">
+                <a:latin typeface="Consolas" panose="020B0609020204030204" pitchFamily="49" charset="0"/>
+              </a:rPr>
+              <a:t>step_timeout</a:t>
+            </a:r>
+            <a:r>
+              <a:rPr lang="en-US" sz="1400" dirty="0"/>
+              <a:t> – The maximum time in seconds that an agent may spend on a single step. If an agent exceeds this time, it will return with an error.</a:t>
+            </a:r>
           </a:p>
           <a:p>
             <a:pPr lvl="2">
@@ -4753,7 +4765,7 @@
         </p:blipFill>
         <p:spPr>
           <a:xfrm>
-            <a:off x="4556227" y="1596967"/>
+            <a:off x="4544195" y="1615014"/>
             <a:ext cx="1224133" cy="314369"/>
           </a:xfrm>
           <a:prstGeom prst="rect">
@@ -4783,7 +4795,7 @@
         </p:blipFill>
         <p:spPr>
           <a:xfrm>
-            <a:off x="4459973" y="5363314"/>
+            <a:off x="4496067" y="5309172"/>
             <a:ext cx="1151580" cy="234139"/>
           </a:xfrm>
           <a:prstGeom prst="rect">
@@ -5509,44 +5521,12 @@
           <a:chExt cx="0" cy="0"/>
         </a:xfrm>
       </p:grpSpPr>
-      <p:sp>
-        <p:nvSpPr>
-          <p:cNvPr id="2" name="Title 1">
-            <a:extLst>
-              <a:ext uri="{FF2B5EF4-FFF2-40B4-BE49-F238E27FC236}">
-                <a16:creationId xmlns:a16="http://schemas.microsoft.com/office/drawing/2014/main" id="{B728E865-4E61-6D9D-E688-3FEFE59B58EA}"/>
-              </a:ext>
-            </a:extLst>
-          </p:cNvPr>
-          <p:cNvSpPr>
-            <a:spLocks noGrp="1"/>
-          </p:cNvSpPr>
-          <p:nvPr>
-            <p:ph type="title"/>
-          </p:nvPr>
-        </p:nvSpPr>
-        <p:spPr/>
-        <p:txBody>
-          <a:bodyPr/>
-          <a:lstStyle/>
-          <a:p>
-            <a:r>
-              <a:rPr lang="en-US" dirty="0" err="1"/>
-              <a:t>Quickstart</a:t>
-            </a:r>
-            <a:r>
-              <a:rPr lang="en-US" dirty="0"/>
-              <a:t> - 1</a:t>
-            </a:r>
-          </a:p>
-        </p:txBody>
-      </p:sp>
       <p:pic>
         <p:nvPicPr>
-          <p:cNvPr id="5" name="Picture 4">
-            <a:extLst>
-              <a:ext uri="{FF2B5EF4-FFF2-40B4-BE49-F238E27FC236}">
-                <a16:creationId xmlns:a16="http://schemas.microsoft.com/office/drawing/2014/main" id="{208C5D4C-6AAD-1D52-BBBD-A5DB2E418F51}"/>
+          <p:cNvPr id="4" name="Picture 3">
+            <a:extLst>
+              <a:ext uri="{FF2B5EF4-FFF2-40B4-BE49-F238E27FC236}">
+                <a16:creationId xmlns:a16="http://schemas.microsoft.com/office/drawing/2014/main" id="{336FE4BD-01EC-0428-C393-C237703813AD}"/>
               </a:ext>
             </a:extLst>
           </p:cNvPr>
@@ -5563,14 +5543,46 @@
         </p:blipFill>
         <p:spPr>
           <a:xfrm>
-            <a:off x="1671852" y="1269640"/>
-            <a:ext cx="9069277" cy="5486001"/>
+            <a:off x="1672389" y="1221397"/>
+            <a:ext cx="9603205" cy="4743422"/>
           </a:xfrm>
           <a:prstGeom prst="rect">
             <a:avLst/>
           </a:prstGeom>
         </p:spPr>
       </p:pic>
+      <p:sp>
+        <p:nvSpPr>
+          <p:cNvPr id="2" name="Title 1">
+            <a:extLst>
+              <a:ext uri="{FF2B5EF4-FFF2-40B4-BE49-F238E27FC236}">
+                <a16:creationId xmlns:a16="http://schemas.microsoft.com/office/drawing/2014/main" id="{B728E865-4E61-6D9D-E688-3FEFE59B58EA}"/>
+              </a:ext>
+            </a:extLst>
+          </p:cNvPr>
+          <p:cNvSpPr>
+            <a:spLocks noGrp="1"/>
+          </p:cNvSpPr>
+          <p:nvPr>
+            <p:ph type="title"/>
+          </p:nvPr>
+        </p:nvSpPr>
+        <p:spPr/>
+        <p:txBody>
+          <a:bodyPr/>
+          <a:lstStyle/>
+          <a:p>
+            <a:r>
+              <a:rPr lang="en-US" dirty="0" err="1"/>
+              <a:t>Quickstart</a:t>
+            </a:r>
+            <a:r>
+              <a:rPr lang="en-US" dirty="0"/>
+              <a:t> - 1</a:t>
+            </a:r>
+          </a:p>
+        </p:txBody>
+      </p:sp>
       <p:sp>
         <p:nvSpPr>
           <p:cNvPr id="6" name="Rectangle 5">
@@ -5682,7 +5694,7 @@
         </p:nvSpPr>
         <p:spPr>
           <a:xfrm>
-            <a:off x="3533775" y="4805363"/>
+            <a:off x="6004884" y="5521998"/>
             <a:ext cx="938213" cy="347303"/>
           </a:xfrm>
           <a:prstGeom prst="rect">
@@ -5785,44 +5797,12 @@
           <a:chExt cx="0" cy="0"/>
         </a:xfrm>
       </p:grpSpPr>
-      <p:sp>
-        <p:nvSpPr>
-          <p:cNvPr id="2" name="Title 1">
-            <a:extLst>
-              <a:ext uri="{FF2B5EF4-FFF2-40B4-BE49-F238E27FC236}">
-                <a16:creationId xmlns:a16="http://schemas.microsoft.com/office/drawing/2014/main" id="{B728E865-4E61-6D9D-E688-3FEFE59B58EA}"/>
-              </a:ext>
-            </a:extLst>
-          </p:cNvPr>
-          <p:cNvSpPr>
-            <a:spLocks noGrp="1"/>
-          </p:cNvSpPr>
-          <p:nvPr>
-            <p:ph type="title"/>
-          </p:nvPr>
-        </p:nvSpPr>
-        <p:spPr/>
-        <p:txBody>
-          <a:bodyPr/>
-          <a:lstStyle/>
-          <a:p>
-            <a:r>
-              <a:rPr lang="en-US" dirty="0" err="1"/>
-              <a:t>Quickstart</a:t>
-            </a:r>
-            <a:r>
-              <a:rPr lang="en-US" dirty="0"/>
-              <a:t> - 2</a:t>
-            </a:r>
-          </a:p>
-        </p:txBody>
-      </p:sp>
       <p:pic>
         <p:nvPicPr>
-          <p:cNvPr id="4" name="Picture 3">
-            <a:extLst>
-              <a:ext uri="{FF2B5EF4-FFF2-40B4-BE49-F238E27FC236}">
-                <a16:creationId xmlns:a16="http://schemas.microsoft.com/office/drawing/2014/main" id="{5933926B-D139-8892-8F5F-B8DBDA3DF22E}"/>
+          <p:cNvPr id="11" name="Picture 10">
+            <a:extLst>
+              <a:ext uri="{FF2B5EF4-FFF2-40B4-BE49-F238E27FC236}">
+                <a16:creationId xmlns:a16="http://schemas.microsoft.com/office/drawing/2014/main" id="{43D274A9-B7EB-1924-456F-86278299995C}"/>
               </a:ext>
             </a:extLst>
           </p:cNvPr>
@@ -5839,8 +5819,8 @@
         </p:blipFill>
         <p:spPr>
           <a:xfrm>
-            <a:off x="0" y="1330568"/>
-            <a:ext cx="8677530" cy="2190554"/>
+            <a:off x="3015703" y="3708639"/>
+            <a:ext cx="8453658" cy="2440720"/>
           </a:xfrm>
           <a:prstGeom prst="rect">
             <a:avLst/>
@@ -5849,10 +5829,10 @@
       </p:pic>
       <p:pic>
         <p:nvPicPr>
-          <p:cNvPr id="5" name="Picture 4">
-            <a:extLst>
-              <a:ext uri="{FF2B5EF4-FFF2-40B4-BE49-F238E27FC236}">
-                <a16:creationId xmlns:a16="http://schemas.microsoft.com/office/drawing/2014/main" id="{92FD0CEB-03DB-08BE-7956-D1AA653754EB}"/>
+          <p:cNvPr id="8" name="Picture 7">
+            <a:extLst>
+              <a:ext uri="{FF2B5EF4-FFF2-40B4-BE49-F238E27FC236}">
+                <a16:creationId xmlns:a16="http://schemas.microsoft.com/office/drawing/2014/main" id="{DDE5CE38-FE74-234F-B4A0-A000680BF8C8}"/>
               </a:ext>
             </a:extLst>
           </p:cNvPr>
@@ -5869,14 +5849,46 @@
         </p:blipFill>
         <p:spPr>
           <a:xfrm>
-            <a:off x="2852381" y="3635202"/>
-            <a:ext cx="9189493" cy="2857673"/>
+            <a:off x="0" y="1333986"/>
+            <a:ext cx="8808448" cy="2178297"/>
           </a:xfrm>
           <a:prstGeom prst="rect">
             <a:avLst/>
           </a:prstGeom>
         </p:spPr>
       </p:pic>
+      <p:sp>
+        <p:nvSpPr>
+          <p:cNvPr id="2" name="Title 1">
+            <a:extLst>
+              <a:ext uri="{FF2B5EF4-FFF2-40B4-BE49-F238E27FC236}">
+                <a16:creationId xmlns:a16="http://schemas.microsoft.com/office/drawing/2014/main" id="{B728E865-4E61-6D9D-E688-3FEFE59B58EA}"/>
+              </a:ext>
+            </a:extLst>
+          </p:cNvPr>
+          <p:cNvSpPr>
+            <a:spLocks noGrp="1"/>
+          </p:cNvSpPr>
+          <p:nvPr>
+            <p:ph type="title"/>
+          </p:nvPr>
+        </p:nvSpPr>
+        <p:spPr/>
+        <p:txBody>
+          <a:bodyPr/>
+          <a:lstStyle/>
+          <a:p>
+            <a:r>
+              <a:rPr lang="en-US" dirty="0" err="1"/>
+              <a:t>Quickstart</a:t>
+            </a:r>
+            <a:r>
+              <a:rPr lang="en-US" dirty="0"/>
+              <a:t> - 2</a:t>
+            </a:r>
+          </a:p>
+        </p:txBody>
+      </p:sp>
       <p:sp>
         <p:nvSpPr>
           <p:cNvPr id="6" name="Rectangle 5">

</xml_diff>

<commit_message>
Slightly improves MistralAI support, adds additional endpoints
- adds endpoints to view available models and tools
- changes how MistralAI models are handled to make it easier for them to use tools. This does not work perfectly yet, and Mistral models will occasionally return an insufficient response or hallucinate model usage.
- cleans up output from models
- updates requirements.txt
- switches to use custom langgraph agent instead of the base agent code from langchain
</commit_message>
<xml_diff>
--- a/ToxPipe API Guide.pptx
+++ b/ToxPipe API Guide.pptx
@@ -268,7 +268,7 @@
           <a:p>
             <a:fld id="{2887AE02-B111-4481-B2BD-B82CAADB2540}" type="datetimeFigureOut">
               <a:rPr lang="en-US" smtClean="0"/>
-              <a:t>12/5/2024</a:t>
+              <a:t>12/12/2024</a:t>
             </a:fld>
             <a:endParaRPr lang="en-US"/>
           </a:p>
@@ -466,7 +466,7 @@
           <a:p>
             <a:fld id="{2887AE02-B111-4481-B2BD-B82CAADB2540}" type="datetimeFigureOut">
               <a:rPr lang="en-US" smtClean="0"/>
-              <a:t>12/5/2024</a:t>
+              <a:t>12/12/2024</a:t>
             </a:fld>
             <a:endParaRPr lang="en-US"/>
           </a:p>
@@ -674,7 +674,7 @@
           <a:p>
             <a:fld id="{2887AE02-B111-4481-B2BD-B82CAADB2540}" type="datetimeFigureOut">
               <a:rPr lang="en-US" smtClean="0"/>
-              <a:t>12/5/2024</a:t>
+              <a:t>12/12/2024</a:t>
             </a:fld>
             <a:endParaRPr lang="en-US"/>
           </a:p>
@@ -872,7 +872,7 @@
           <a:p>
             <a:fld id="{2887AE02-B111-4481-B2BD-B82CAADB2540}" type="datetimeFigureOut">
               <a:rPr lang="en-US" smtClean="0"/>
-              <a:t>12/5/2024</a:t>
+              <a:t>12/12/2024</a:t>
             </a:fld>
             <a:endParaRPr lang="en-US"/>
           </a:p>
@@ -1147,7 +1147,7 @@
           <a:p>
             <a:fld id="{2887AE02-B111-4481-B2BD-B82CAADB2540}" type="datetimeFigureOut">
               <a:rPr lang="en-US" smtClean="0"/>
-              <a:t>12/5/2024</a:t>
+              <a:t>12/12/2024</a:t>
             </a:fld>
             <a:endParaRPr lang="en-US"/>
           </a:p>
@@ -1412,7 +1412,7 @@
           <a:p>
             <a:fld id="{2887AE02-B111-4481-B2BD-B82CAADB2540}" type="datetimeFigureOut">
               <a:rPr lang="en-US" smtClean="0"/>
-              <a:t>12/5/2024</a:t>
+              <a:t>12/12/2024</a:t>
             </a:fld>
             <a:endParaRPr lang="en-US"/>
           </a:p>
@@ -1824,7 +1824,7 @@
           <a:p>
             <a:fld id="{2887AE02-B111-4481-B2BD-B82CAADB2540}" type="datetimeFigureOut">
               <a:rPr lang="en-US" smtClean="0"/>
-              <a:t>12/5/2024</a:t>
+              <a:t>12/12/2024</a:t>
             </a:fld>
             <a:endParaRPr lang="en-US"/>
           </a:p>
@@ -1965,7 +1965,7 @@
           <a:p>
             <a:fld id="{2887AE02-B111-4481-B2BD-B82CAADB2540}" type="datetimeFigureOut">
               <a:rPr lang="en-US" smtClean="0"/>
-              <a:t>12/5/2024</a:t>
+              <a:t>12/12/2024</a:t>
             </a:fld>
             <a:endParaRPr lang="en-US"/>
           </a:p>
@@ -2078,7 +2078,7 @@
           <a:p>
             <a:fld id="{2887AE02-B111-4481-B2BD-B82CAADB2540}" type="datetimeFigureOut">
               <a:rPr lang="en-US" smtClean="0"/>
-              <a:t>12/5/2024</a:t>
+              <a:t>12/12/2024</a:t>
             </a:fld>
             <a:endParaRPr lang="en-US"/>
           </a:p>
@@ -2389,7 +2389,7 @@
           <a:p>
             <a:fld id="{2887AE02-B111-4481-B2BD-B82CAADB2540}" type="datetimeFigureOut">
               <a:rPr lang="en-US" smtClean="0"/>
-              <a:t>12/5/2024</a:t>
+              <a:t>12/12/2024</a:t>
             </a:fld>
             <a:endParaRPr lang="en-US"/>
           </a:p>
@@ -2677,7 +2677,7 @@
           <a:p>
             <a:fld id="{2887AE02-B111-4481-B2BD-B82CAADB2540}" type="datetimeFigureOut">
               <a:rPr lang="en-US" smtClean="0"/>
-              <a:t>12/5/2024</a:t>
+              <a:t>12/12/2024</a:t>
             </a:fld>
             <a:endParaRPr lang="en-US"/>
           </a:p>
@@ -2918,7 +2918,7 @@
           <a:p>
             <a:fld id="{2887AE02-B111-4481-B2BD-B82CAADB2540}" type="datetimeFigureOut">
               <a:rPr lang="en-US" smtClean="0"/>
-              <a:t>12/5/2024</a:t>
+              <a:t>12/12/2024</a:t>
             </a:fld>
             <a:endParaRPr lang="en-US"/>
           </a:p>
@@ -3390,7 +3390,7 @@
           <a:p>
             <a:r>
               <a:rPr lang="en-US" dirty="0"/>
-              <a:t>Last Updated: Dec. 5, 2024</a:t>
+              <a:t>Last Updated: Dec. 12, 2024</a:t>
             </a:r>
           </a:p>
         </p:txBody>
@@ -5259,6 +5259,24 @@
               </a:rPr>
               <a:t>MistralAI</a:t>
             </a:r>
+            <a:r>
+              <a:rPr lang="en-US" sz="1200" b="1" dirty="0">
+                <a:effectLst/>
+              </a:rPr>
+              <a:t> </a:t>
+            </a:r>
+            <a:r>
+              <a:rPr lang="en-US" sz="1200" b="0" dirty="0">
+                <a:effectLst/>
+              </a:rPr>
+              <a:t>(not fully supported – tools occasionally work, but the models are prone to hallucination. These may </a:t>
+            </a:r>
+            <a:r>
+              <a:rPr lang="en-US" sz="1200" b="0">
+                <a:effectLst/>
+              </a:rPr>
+              <a:t>also fail to take multiple agentic steps.)</a:t>
+            </a:r>
             <a:endParaRPr lang="en-US" sz="1200" b="1" dirty="0">
               <a:effectLst/>
             </a:endParaRPr>
@@ -5291,9 +5309,6 @@
             </a:pPr>
             <a:r>
               <a:rPr lang="en-US" sz="1200" b="0" dirty="0">
-                <a:solidFill>
-                  <a:srgbClr val="FF0000"/>
-                </a:solidFill>
                 <a:effectLst/>
                 <a:latin typeface="Consolas" panose="020B0609020204030204" pitchFamily="49" charset="0"/>
               </a:rPr>
@@ -5311,9 +5326,6 @@
             </a:pPr>
             <a:r>
               <a:rPr lang="en-US" sz="1200" b="0" dirty="0">
-                <a:solidFill>
-                  <a:srgbClr val="FF0000"/>
-                </a:solidFill>
                 <a:effectLst/>
                 <a:latin typeface="Consolas" panose="020B0609020204030204" pitchFamily="49" charset="0"/>
               </a:rPr>

</xml_diff>

<commit_message>
Adds FastAPI tags to API GUI
</commit_message>
<xml_diff>
--- a/ToxPipe API Guide.pptx
+++ b/ToxPipe API Guide.pptx
@@ -5269,13 +5269,7 @@
               <a:rPr lang="en-US" sz="1200" b="0" dirty="0">
                 <a:effectLst/>
               </a:rPr>
-              <a:t>(not fully supported – tools occasionally work, but the models are prone to hallucination. These may </a:t>
-            </a:r>
-            <a:r>
-              <a:rPr lang="en-US" sz="1200" b="0">
-                <a:effectLst/>
-              </a:rPr>
-              <a:t>also fail to take multiple agentic steps.)</a:t>
+              <a:t>(not fully supported – tools occasionally work, but the models are prone to hallucination. These may also fail to take multiple agentic steps.)</a:t>
             </a:r>
             <a:endParaRPr lang="en-US" sz="1200" b="1" dirty="0">
               <a:effectLst/>
@@ -5362,8 +5356,23 @@
               <a:rPr lang="en-US" sz="1200" b="1" dirty="0">
                 <a:effectLst/>
               </a:rPr>
-              <a:t>Amazon</a:t>
-            </a:r>
+              <a:t>Amazon </a:t>
+            </a:r>
+            <a:r>
+              <a:rPr lang="en-US" sz="1200" dirty="0">
+                <a:effectLst/>
+              </a:rPr>
+              <a:t>(Gives decent answers but doesn’t seem to use tools – probably has expansive </a:t>
+            </a:r>
+            <a:r>
+              <a:rPr lang="en-US" sz="1200">
+                <a:effectLst/>
+              </a:rPr>
+              <a:t>training data.)</a:t>
+            </a:r>
+            <a:endParaRPr lang="en-US" sz="1200" b="1" dirty="0">
+              <a:effectLst/>
+            </a:endParaRPr>
           </a:p>
           <a:p>
             <a:pPr lvl="1">
@@ -5376,9 +5385,6 @@
             </a:pPr>
             <a:r>
               <a:rPr lang="en-US" sz="1200" b="0" dirty="0">
-                <a:solidFill>
-                  <a:srgbClr val="FF0000"/>
-                </a:solidFill>
                 <a:effectLst/>
                 <a:latin typeface="Consolas" panose="020B0609020204030204" pitchFamily="49" charset="0"/>
               </a:rPr>

</xml_diff>

<commit_message>
Refactor + persistent storage
- Adds Postgres connection for persistent agentic memory
- Adds option to configure max retry number of an agent
- Overhauls literature search to be more effective
- Overhauls internal prompt for LLM to allow for more consistent formatting, tool use, and allowance of knowledge from the model's training data
- Improves tool descriptions, so more tools should be used going forward
</commit_message>
<xml_diff>
--- a/ToxPipe API Guide.pptx
+++ b/ToxPipe API Guide.pptx
@@ -4880,7 +4880,7 @@
         <p:spPr>
           <a:xfrm>
             <a:off x="838200" y="1473868"/>
-            <a:ext cx="10515600" cy="5119437"/>
+            <a:ext cx="10515600" cy="5227721"/>
           </a:xfrm>
         </p:spPr>
         <p:txBody>
@@ -4901,11 +4901,11 @@
             <a:r>
               <a:rPr lang="en-US" sz="1200" b="1" dirty="0">
                 <a:solidFill>
-                  <a:srgbClr val="FF0000"/>
+                  <a:srgbClr val="00B050"/>
                 </a:solidFill>
                 <a:effectLst/>
               </a:rPr>
-              <a:t>Red</a:t>
+              <a:t>Green</a:t>
             </a:r>
             <a:r>
               <a:rPr lang="en-US" sz="1200" b="1" dirty="0">
@@ -4917,8 +4917,66 @@
               <a:rPr lang="en-US" sz="1200" dirty="0">
                 <a:effectLst/>
               </a:rPr>
-              <a:t>= recommended, tested with tools</a:t>
-            </a:r>
+              <a:t>= Recommended, tested with tools.</a:t>
+            </a:r>
+          </a:p>
+          <a:p>
+            <a:pPr marL="0" indent="0">
+              <a:lnSpc>
+                <a:spcPct val="100000"/>
+              </a:lnSpc>
+              <a:spcBef>
+                <a:spcPts val="0"/>
+              </a:spcBef>
+              <a:buNone/>
+            </a:pPr>
+            <a:r>
+              <a:rPr lang="en-US" sz="1200" b="1" dirty="0">
+                <a:solidFill>
+                  <a:schemeClr val="accent4">
+                    <a:lumMod val="75000"/>
+                  </a:schemeClr>
+                </a:solidFill>
+              </a:rPr>
+              <a:t>Yellow</a:t>
+            </a:r>
+            <a:r>
+              <a:rPr lang="en-US" sz="1200" dirty="0"/>
+              <a:t> = Supported, can use tools but may fail to take proper thought chains. May require multiple repeat queries to get a satisfactory answer,</a:t>
+            </a:r>
+          </a:p>
+          <a:p>
+            <a:pPr marL="0" indent="0">
+              <a:lnSpc>
+                <a:spcPct val="100000"/>
+              </a:lnSpc>
+              <a:spcBef>
+                <a:spcPts val="0"/>
+              </a:spcBef>
+              <a:buNone/>
+            </a:pPr>
+            <a:r>
+              <a:rPr lang="en-US" sz="1200" b="1" dirty="0">
+                <a:solidFill>
+                  <a:srgbClr val="C00000"/>
+                </a:solidFill>
+                <a:effectLst/>
+              </a:rPr>
+              <a:t>Red</a:t>
+            </a:r>
+            <a:r>
+              <a:rPr lang="en-US" sz="1200" dirty="0">
+                <a:effectLst/>
+              </a:rPr>
+              <a:t> = Unsupported, </a:t>
+            </a:r>
+            <a:r>
+              <a:rPr lang="en-US" sz="1200" dirty="0"/>
+              <a:t>may be used but will not properly use tools. These models either hallucinate or rely on training data.</a:t>
+            </a:r>
+            <a:endParaRPr lang="en-US" sz="1200" dirty="0">
+              <a:effectLst/>
+            </a:endParaRPr>
           </a:p>
           <a:p>
             <a:pPr>
@@ -4947,7 +5005,10 @@
               </a:spcBef>
             </a:pPr>
             <a:r>
-              <a:rPr lang="en-US" sz="1200" b="0" dirty="0">
+              <a:rPr lang="en-US" sz="1200" b="1" dirty="0">
+                <a:solidFill>
+                  <a:srgbClr val="00B050"/>
+                </a:solidFill>
                 <a:effectLst/>
                 <a:latin typeface="Consolas" panose="020B0609020204030204" pitchFamily="49" charset="0"/>
               </a:rPr>
@@ -4964,7 +5025,10 @@
               </a:spcBef>
             </a:pPr>
             <a:r>
-              <a:rPr lang="en-US" sz="1200" b="0" dirty="0">
+              <a:rPr lang="en-US" sz="1200" b="1" dirty="0">
+                <a:solidFill>
+                  <a:srgbClr val="C00000"/>
+                </a:solidFill>
                 <a:effectLst/>
                 <a:latin typeface="Consolas" panose="020B0609020204030204" pitchFamily="49" charset="0"/>
               </a:rPr>
@@ -4981,9 +5045,9 @@
               </a:spcBef>
             </a:pPr>
             <a:r>
-              <a:rPr lang="en-US" sz="1200" b="0" dirty="0">
-                <a:solidFill>
-                  <a:srgbClr val="FF0000"/>
+              <a:rPr lang="en-US" sz="1200" b="1" dirty="0">
+                <a:solidFill>
+                  <a:srgbClr val="00B050"/>
                 </a:solidFill>
                 <a:effectLst/>
                 <a:latin typeface="Consolas" panose="020B0609020204030204" pitchFamily="49" charset="0"/>
@@ -5001,9 +5065,9 @@
               </a:spcBef>
             </a:pPr>
             <a:r>
-              <a:rPr lang="en-US" sz="1200" b="0" dirty="0">
-                <a:solidFill>
-                  <a:srgbClr val="FF0000"/>
+              <a:rPr lang="en-US" sz="1200" b="1" dirty="0">
+                <a:solidFill>
+                  <a:srgbClr val="00B050"/>
                 </a:solidFill>
                 <a:effectLst/>
                 <a:latin typeface="Consolas" panose="020B0609020204030204" pitchFamily="49" charset="0"/>
@@ -5026,13 +5090,6 @@
               </a:rPr>
               <a:t>Meta</a:t>
             </a:r>
-            <a:r>
-              <a:rPr lang="en-US" sz="1200" b="0" dirty="0">
-                <a:effectLst/>
-              </a:rPr>
-              <a:t> (not fully supported – doesn’t work with tools)</a:t>
-            </a:r>
-            <a:endParaRPr lang="en-US" sz="1200" dirty="0"/>
           </a:p>
           <a:p>
             <a:pPr lvl="1">
@@ -5044,11 +5101,32 @@
               </a:spcBef>
             </a:pPr>
             <a:r>
-              <a:rPr lang="en-US" sz="1200" b="0" dirty="0">
+              <a:rPr lang="en-US" sz="1200" b="1" dirty="0">
+                <a:solidFill>
+                  <a:schemeClr val="accent4">
+                    <a:lumMod val="75000"/>
+                  </a:schemeClr>
+                </a:solidFill>
                 <a:effectLst/>
                 <a:latin typeface="Consolas" panose="020B0609020204030204" pitchFamily="49" charset="0"/>
               </a:rPr>
               <a:t>llama3-1-70b</a:t>
+            </a:r>
+          </a:p>
+          <a:p>
+            <a:pPr>
+              <a:lnSpc>
+                <a:spcPct val="100000"/>
+              </a:lnSpc>
+              <a:spcBef>
+                <a:spcPts val="0"/>
+              </a:spcBef>
+            </a:pPr>
+            <a:r>
+              <a:rPr lang="en-US" sz="1200" b="1" dirty="0">
+                <a:effectLst/>
+              </a:rPr>
+              <a:t>Azure OpenAI</a:t>
             </a:r>
           </a:p>
           <a:p>
@@ -5061,11 +5139,14 @@
               </a:spcBef>
             </a:pPr>
             <a:r>
-              <a:rPr lang="en-US" sz="1200" b="0" dirty="0">
+              <a:rPr lang="en-US" sz="1200" b="1" dirty="0">
+                <a:solidFill>
+                  <a:srgbClr val="00B050"/>
+                </a:solidFill>
                 <a:effectLst/>
                 <a:latin typeface="Consolas" panose="020B0609020204030204" pitchFamily="49" charset="0"/>
               </a:rPr>
-              <a:t>llama3-1-8b</a:t>
+              <a:t>azure-gpt-4o</a:t>
             </a:r>
           </a:p>
           <a:p>
@@ -5078,11 +5159,16 @@
               </a:spcBef>
             </a:pPr>
             <a:r>
-              <a:rPr lang="en-US" sz="1200" b="0" dirty="0">
+              <a:rPr lang="en-US" sz="1200" b="1" dirty="0">
+                <a:solidFill>
+                  <a:schemeClr val="accent4">
+                    <a:lumMod val="75000"/>
+                  </a:schemeClr>
+                </a:solidFill>
                 <a:effectLst/>
                 <a:latin typeface="Consolas" panose="020B0609020204030204" pitchFamily="49" charset="0"/>
               </a:rPr>
-              <a:t>openbiollm-llama3-70b</a:t>
+              <a:t>azure-gpt-3.5-turbo (cannot handle large/complex queries)</a:t>
             </a:r>
           </a:p>
           <a:p>
@@ -5095,11 +5181,76 @@
               </a:spcBef>
             </a:pPr>
             <a:r>
-              <a:rPr lang="en-US" sz="1200" b="0" dirty="0">
+              <a:rPr lang="en-US" sz="1200" b="1" dirty="0">
+                <a:solidFill>
+                  <a:schemeClr val="accent4">
+                    <a:lumMod val="75000"/>
+                  </a:schemeClr>
+                </a:solidFill>
                 <a:effectLst/>
                 <a:latin typeface="Consolas" panose="020B0609020204030204" pitchFamily="49" charset="0"/>
               </a:rPr>
-              <a:t>llama2-13b</a:t>
+              <a:t>azure-gpt-4o-mini (may need large number of max iterations)</a:t>
+            </a:r>
+          </a:p>
+          <a:p>
+            <a:pPr lvl="1">
+              <a:lnSpc>
+                <a:spcPct val="100000"/>
+              </a:lnSpc>
+              <a:spcBef>
+                <a:spcPts val="0"/>
+              </a:spcBef>
+            </a:pPr>
+            <a:r>
+              <a:rPr lang="en-US" sz="1200" b="1" dirty="0">
+                <a:solidFill>
+                  <a:srgbClr val="00B050"/>
+                </a:solidFill>
+                <a:effectLst/>
+                <a:latin typeface="Consolas" panose="020B0609020204030204" pitchFamily="49" charset="0"/>
+              </a:rPr>
+              <a:t>azure-gpt-3.5-turbo-16k</a:t>
+            </a:r>
+          </a:p>
+          <a:p>
+            <a:pPr lvl="1">
+              <a:lnSpc>
+                <a:spcPct val="100000"/>
+              </a:lnSpc>
+              <a:spcBef>
+                <a:spcPts val="0"/>
+              </a:spcBef>
+            </a:pPr>
+            <a:r>
+              <a:rPr lang="en-US" sz="1200" b="1" dirty="0">
+                <a:solidFill>
+                  <a:srgbClr val="00B050"/>
+                </a:solidFill>
+                <a:effectLst/>
+                <a:latin typeface="Consolas" panose="020B0609020204030204" pitchFamily="49" charset="0"/>
+              </a:rPr>
+              <a:t>azure-gpt-4-turbo-20240409</a:t>
+            </a:r>
+          </a:p>
+          <a:p>
+            <a:pPr lvl="1">
+              <a:lnSpc>
+                <a:spcPct val="100000"/>
+              </a:lnSpc>
+              <a:spcBef>
+                <a:spcPts val="0"/>
+              </a:spcBef>
+            </a:pPr>
+            <a:r>
+              <a:rPr lang="en-US" sz="1200" b="1" dirty="0">
+                <a:solidFill>
+                  <a:srgbClr val="00B050"/>
+                </a:solidFill>
+                <a:effectLst/>
+                <a:latin typeface="Consolas" panose="020B0609020204030204" pitchFamily="49" charset="0"/>
+              </a:rPr>
+              <a:t>azure-gpt-4</a:t>
             </a:r>
           </a:p>
           <a:p>
@@ -5112,17 +5263,14 @@
               </a:spcBef>
             </a:pPr>
             <a:r>
-              <a:rPr lang="en-US" sz="1200" b="1" dirty="0">
+              <a:rPr lang="en-US" sz="1200" b="1" dirty="0" err="1">
                 <a:effectLst/>
               </a:rPr>
-              <a:t>Azure OpenAI </a:t>
-            </a:r>
-            <a:r>
-              <a:rPr lang="en-US" sz="1200" b="0" dirty="0">
-                <a:effectLst/>
-              </a:rPr>
-              <a:t>(recommended)</a:t>
-            </a:r>
+              <a:t>MistralAI</a:t>
+            </a:r>
+            <a:endParaRPr lang="en-US" sz="1200" b="1" dirty="0">
+              <a:effectLst/>
+            </a:endParaRPr>
           </a:p>
           <a:p>
             <a:pPr lvl="1">
@@ -5134,14 +5282,16 @@
               </a:spcBef>
             </a:pPr>
             <a:r>
-              <a:rPr lang="en-US" sz="1200" b="0" dirty="0">
-                <a:solidFill>
-                  <a:srgbClr val="FF0000"/>
+              <a:rPr lang="en-US" sz="1200" b="1" dirty="0">
+                <a:solidFill>
+                  <a:schemeClr val="accent4">
+                    <a:lumMod val="75000"/>
+                  </a:schemeClr>
                 </a:solidFill>
                 <a:effectLst/>
                 <a:latin typeface="Consolas" panose="020B0609020204030204" pitchFamily="49" charset="0"/>
               </a:rPr>
-              <a:t>azure-gpt-4o</a:t>
+              <a:t>mistral-large-2</a:t>
             </a:r>
           </a:p>
           <a:p>
@@ -5154,14 +5304,14 @@
               </a:spcBef>
             </a:pPr>
             <a:r>
-              <a:rPr lang="en-US" sz="1200" b="0" dirty="0">
-                <a:solidFill>
-                  <a:srgbClr val="FF0000"/>
+              <a:rPr lang="en-US" sz="1200" b="1" dirty="0">
+                <a:solidFill>
+                  <a:srgbClr val="C00000"/>
                 </a:solidFill>
                 <a:effectLst/>
                 <a:latin typeface="Consolas" panose="020B0609020204030204" pitchFamily="49" charset="0"/>
               </a:rPr>
-              <a:t>azure-gpt-3.5-turbo</a:t>
+              <a:t>mistral-large</a:t>
             </a:r>
           </a:p>
           <a:p>
@@ -5174,14 +5324,14 @@
               </a:spcBef>
             </a:pPr>
             <a:r>
-              <a:rPr lang="en-US" sz="1200" b="0" dirty="0">
-                <a:solidFill>
-                  <a:srgbClr val="FF0000"/>
+              <a:rPr lang="en-US" sz="1200" b="1" dirty="0">
+                <a:solidFill>
+                  <a:srgbClr val="C00000"/>
                 </a:solidFill>
                 <a:effectLst/>
                 <a:latin typeface="Consolas" panose="020B0609020204030204" pitchFamily="49" charset="0"/>
               </a:rPr>
-              <a:t>azure-gpt-4o-mini</a:t>
+              <a:t>mistral-7b-instruct</a:t>
             </a:r>
           </a:p>
           <a:p>
@@ -5194,14 +5344,32 @@
               </a:spcBef>
             </a:pPr>
             <a:r>
-              <a:rPr lang="en-US" sz="1200" b="0" dirty="0">
-                <a:solidFill>
-                  <a:srgbClr val="FF0000"/>
+              <a:rPr lang="en-US" sz="1200" b="1" dirty="0">
+                <a:solidFill>
+                  <a:schemeClr val="accent4">
+                    <a:lumMod val="75000"/>
+                  </a:schemeClr>
                 </a:solidFill>
                 <a:effectLst/>
                 <a:latin typeface="Consolas" panose="020B0609020204030204" pitchFamily="49" charset="0"/>
               </a:rPr>
-              <a:t>azure-gpt-3.5-turbo-16k</a:t>
+              <a:t>mixtral-8x7b-instruct</a:t>
+            </a:r>
+          </a:p>
+          <a:p>
+            <a:pPr>
+              <a:lnSpc>
+                <a:spcPct val="100000"/>
+              </a:lnSpc>
+              <a:spcBef>
+                <a:spcPts val="0"/>
+              </a:spcBef>
+            </a:pPr>
+            <a:r>
+              <a:rPr lang="en-US" sz="1200" b="1" dirty="0">
+                <a:effectLst/>
+              </a:rPr>
+              <a:t>Amazon</a:t>
             </a:r>
           </a:p>
           <a:p>
@@ -5214,14 +5382,30 @@
               </a:spcBef>
             </a:pPr>
             <a:r>
-              <a:rPr lang="en-US" sz="1200" b="0" dirty="0">
-                <a:solidFill>
-                  <a:srgbClr val="FF0000"/>
+              <a:rPr lang="en-US" sz="1200" b="1" dirty="0">
+                <a:solidFill>
+                  <a:srgbClr val="C00000"/>
                 </a:solidFill>
                 <a:effectLst/>
                 <a:latin typeface="Consolas" panose="020B0609020204030204" pitchFamily="49" charset="0"/>
               </a:rPr>
-              <a:t>azure-gpt-4-turbo-20240409</a:t>
+              <a:t>amazon-titan-text-premier</a:t>
+            </a:r>
+          </a:p>
+          <a:p>
+            <a:pPr>
+              <a:lnSpc>
+                <a:spcPct val="100000"/>
+              </a:lnSpc>
+              <a:spcBef>
+                <a:spcPts val="0"/>
+              </a:spcBef>
+            </a:pPr>
+            <a:r>
+              <a:rPr lang="en-US" sz="1200" b="1" dirty="0">
+                <a:effectLst/>
+              </a:rPr>
+              <a:t>Cohere</a:t>
             </a:r>
           </a:p>
           <a:p>
@@ -5234,202 +5418,28 @@
               </a:spcBef>
             </a:pPr>
             <a:r>
-              <a:rPr lang="en-US" sz="1200" b="0" dirty="0">
-                <a:solidFill>
-                  <a:srgbClr val="FF0000"/>
+              <a:rPr lang="en-US" sz="1200" b="1" dirty="0">
+                <a:solidFill>
+                  <a:srgbClr val="C00000"/>
                 </a:solidFill>
                 <a:effectLst/>
                 <a:latin typeface="Consolas" panose="020B0609020204030204" pitchFamily="49" charset="0"/>
               </a:rPr>
-              <a:t>azure-gpt-4</a:t>
-            </a:r>
-          </a:p>
-          <a:p>
-            <a:pPr>
-              <a:lnSpc>
-                <a:spcPct val="100000"/>
-              </a:lnSpc>
-              <a:spcBef>
-                <a:spcPts val="0"/>
-              </a:spcBef>
-            </a:pPr>
-            <a:r>
-              <a:rPr lang="en-US" sz="1200" b="1" dirty="0" err="1">
-                <a:effectLst/>
-              </a:rPr>
-              <a:t>MistralAI</a:t>
-            </a:r>
-            <a:r>
-              <a:rPr lang="en-US" sz="1200" b="1" dirty="0">
-                <a:effectLst/>
-              </a:rPr>
-              <a:t> </a:t>
-            </a:r>
-            <a:r>
+              <a:t>cohere-command-r-plus</a:t>
+            </a:r>
+            <a:br>
               <a:rPr lang="en-US" sz="1200" b="0" dirty="0">
-                <a:effectLst/>
-              </a:rPr>
-              <a:t>(not fully supported – tools occasionally work, but the models are prone to hallucination. These may also fail to take multiple agentic steps.)</a:t>
-            </a:r>
-            <a:endParaRPr lang="en-US" sz="1200" b="1" dirty="0">
-              <a:effectLst/>
-            </a:endParaRPr>
-          </a:p>
-          <a:p>
-            <a:pPr lvl="1">
-              <a:lnSpc>
-                <a:spcPct val="100000"/>
-              </a:lnSpc>
-              <a:spcBef>
-                <a:spcPts val="0"/>
-              </a:spcBef>
-            </a:pPr>
-            <a:r>
-              <a:rPr lang="en-US" sz="1200" b="0" dirty="0">
+                <a:solidFill>
+                  <a:srgbClr val="C00000"/>
+                </a:solidFill>
                 <a:effectLst/>
                 <a:latin typeface="Consolas" panose="020B0609020204030204" pitchFamily="49" charset="0"/>
               </a:rPr>
-              <a:t>mistral-large-2</a:t>
-            </a:r>
-          </a:p>
-          <a:p>
-            <a:pPr lvl="1">
-              <a:lnSpc>
-                <a:spcPct val="100000"/>
-              </a:lnSpc>
-              <a:spcBef>
-                <a:spcPts val="0"/>
-              </a:spcBef>
-            </a:pPr>
-            <a:r>
-              <a:rPr lang="en-US" sz="1200" b="0" dirty="0">
-                <a:effectLst/>
-                <a:latin typeface="Consolas" panose="020B0609020204030204" pitchFamily="49" charset="0"/>
-              </a:rPr>
-              <a:t>mistral-large</a:t>
-            </a:r>
-          </a:p>
-          <a:p>
-            <a:pPr lvl="1">
-              <a:lnSpc>
-                <a:spcPct val="100000"/>
-              </a:lnSpc>
-              <a:spcBef>
-                <a:spcPts val="0"/>
-              </a:spcBef>
-            </a:pPr>
-            <a:r>
-              <a:rPr lang="en-US" sz="1200" b="0" dirty="0">
-                <a:effectLst/>
-                <a:latin typeface="Consolas" panose="020B0609020204030204" pitchFamily="49" charset="0"/>
-              </a:rPr>
-              <a:t>mistral-7b-instruct</a:t>
-            </a:r>
-          </a:p>
-          <a:p>
-            <a:pPr lvl="1">
-              <a:lnSpc>
-                <a:spcPct val="100000"/>
-              </a:lnSpc>
-              <a:spcBef>
-                <a:spcPts val="0"/>
-              </a:spcBef>
-            </a:pPr>
-            <a:r>
-              <a:rPr lang="en-US" sz="1200" b="0" dirty="0">
-                <a:effectLst/>
-                <a:latin typeface="Consolas" panose="020B0609020204030204" pitchFamily="49" charset="0"/>
-              </a:rPr>
-              <a:t>mixtral-8x7b-instruct</a:t>
-            </a:r>
-          </a:p>
-          <a:p>
-            <a:pPr>
-              <a:lnSpc>
-                <a:spcPct val="100000"/>
-              </a:lnSpc>
-              <a:spcBef>
-                <a:spcPts val="0"/>
-              </a:spcBef>
-            </a:pPr>
-            <a:r>
-              <a:rPr lang="en-US" sz="1200" b="1" dirty="0">
-                <a:effectLst/>
-              </a:rPr>
-              <a:t>Amazon </a:t>
-            </a:r>
-            <a:r>
-              <a:rPr lang="en-US" sz="1200" dirty="0">
-                <a:effectLst/>
-              </a:rPr>
-              <a:t>(Gives decent answers but doesn’t seem to use tools – probably has expansive </a:t>
-            </a:r>
-            <a:r>
-              <a:rPr lang="en-US" sz="1200">
-                <a:effectLst/>
-              </a:rPr>
-              <a:t>training data.)</a:t>
-            </a:r>
-            <a:endParaRPr lang="en-US" sz="1200" b="1" dirty="0">
-              <a:effectLst/>
-            </a:endParaRPr>
-          </a:p>
-          <a:p>
-            <a:pPr lvl="1">
-              <a:lnSpc>
-                <a:spcPct val="100000"/>
-              </a:lnSpc>
-              <a:spcBef>
-                <a:spcPts val="0"/>
-              </a:spcBef>
-            </a:pPr>
-            <a:r>
-              <a:rPr lang="en-US" sz="1200" b="0" dirty="0">
-                <a:effectLst/>
-                <a:latin typeface="Consolas" panose="020B0609020204030204" pitchFamily="49" charset="0"/>
-              </a:rPr>
-              <a:t>amazon-titan-text-premier</a:t>
-            </a:r>
-          </a:p>
-          <a:p>
-            <a:pPr>
-              <a:lnSpc>
-                <a:spcPct val="100000"/>
-              </a:lnSpc>
-              <a:spcBef>
-                <a:spcPts val="0"/>
-              </a:spcBef>
-            </a:pPr>
-            <a:r>
-              <a:rPr lang="en-US" sz="1200" b="1" dirty="0">
-                <a:effectLst/>
-              </a:rPr>
-              <a:t>Cohere</a:t>
-            </a:r>
-          </a:p>
-          <a:p>
-            <a:pPr lvl="1">
-              <a:lnSpc>
-                <a:spcPct val="100000"/>
-              </a:lnSpc>
-              <a:spcBef>
-                <a:spcPts val="0"/>
-              </a:spcBef>
-            </a:pPr>
-            <a:r>
-              <a:rPr lang="en-US" sz="1200" b="0" dirty="0">
-                <a:effectLst/>
-                <a:latin typeface="Consolas" panose="020B0609020204030204" pitchFamily="49" charset="0"/>
-              </a:rPr>
-              <a:t>cohere-command-r-plus</a:t>
-            </a:r>
-            <a:br>
-              <a:rPr lang="en-US" sz="1200" b="0" dirty="0">
-                <a:effectLst/>
-                <a:latin typeface="Consolas" panose="020B0609020204030204" pitchFamily="49" charset="0"/>
-              </a:rPr>
             </a:br>
             <a:endParaRPr lang="en-US" sz="1200" b="0" dirty="0">
+              <a:solidFill>
+                <a:srgbClr val="C00000"/>
+              </a:solidFill>
               <a:effectLst/>
               <a:latin typeface="Consolas" panose="020B0609020204030204" pitchFamily="49" charset="0"/>
             </a:endParaRPr>

</xml_diff>

<commit_message>
Adds support for azure-o* models
azure-o1
azure-o1-mini
azure-o3-mini
</commit_message>
<xml_diff>
--- a/ToxPipe API Guide.pptx
+++ b/ToxPipe API Guide.pptx
@@ -268,7 +268,7 @@
           <a:p>
             <a:fld id="{2887AE02-B111-4481-B2BD-B82CAADB2540}" type="datetimeFigureOut">
               <a:rPr lang="en-US" smtClean="0"/>
-              <a:t>12/12/2024</a:t>
+              <a:t>2/27/2025</a:t>
             </a:fld>
             <a:endParaRPr lang="en-US"/>
           </a:p>
@@ -466,7 +466,7 @@
           <a:p>
             <a:fld id="{2887AE02-B111-4481-B2BD-B82CAADB2540}" type="datetimeFigureOut">
               <a:rPr lang="en-US" smtClean="0"/>
-              <a:t>12/12/2024</a:t>
+              <a:t>2/27/2025</a:t>
             </a:fld>
             <a:endParaRPr lang="en-US"/>
           </a:p>
@@ -674,7 +674,7 @@
           <a:p>
             <a:fld id="{2887AE02-B111-4481-B2BD-B82CAADB2540}" type="datetimeFigureOut">
               <a:rPr lang="en-US" smtClean="0"/>
-              <a:t>12/12/2024</a:t>
+              <a:t>2/27/2025</a:t>
             </a:fld>
             <a:endParaRPr lang="en-US"/>
           </a:p>
@@ -872,7 +872,7 @@
           <a:p>
             <a:fld id="{2887AE02-B111-4481-B2BD-B82CAADB2540}" type="datetimeFigureOut">
               <a:rPr lang="en-US" smtClean="0"/>
-              <a:t>12/12/2024</a:t>
+              <a:t>2/27/2025</a:t>
             </a:fld>
             <a:endParaRPr lang="en-US"/>
           </a:p>
@@ -1147,7 +1147,7 @@
           <a:p>
             <a:fld id="{2887AE02-B111-4481-B2BD-B82CAADB2540}" type="datetimeFigureOut">
               <a:rPr lang="en-US" smtClean="0"/>
-              <a:t>12/12/2024</a:t>
+              <a:t>2/27/2025</a:t>
             </a:fld>
             <a:endParaRPr lang="en-US"/>
           </a:p>
@@ -1412,7 +1412,7 @@
           <a:p>
             <a:fld id="{2887AE02-B111-4481-B2BD-B82CAADB2540}" type="datetimeFigureOut">
               <a:rPr lang="en-US" smtClean="0"/>
-              <a:t>12/12/2024</a:t>
+              <a:t>2/27/2025</a:t>
             </a:fld>
             <a:endParaRPr lang="en-US"/>
           </a:p>
@@ -1824,7 +1824,7 @@
           <a:p>
             <a:fld id="{2887AE02-B111-4481-B2BD-B82CAADB2540}" type="datetimeFigureOut">
               <a:rPr lang="en-US" smtClean="0"/>
-              <a:t>12/12/2024</a:t>
+              <a:t>2/27/2025</a:t>
             </a:fld>
             <a:endParaRPr lang="en-US"/>
           </a:p>
@@ -1965,7 +1965,7 @@
           <a:p>
             <a:fld id="{2887AE02-B111-4481-B2BD-B82CAADB2540}" type="datetimeFigureOut">
               <a:rPr lang="en-US" smtClean="0"/>
-              <a:t>12/12/2024</a:t>
+              <a:t>2/27/2025</a:t>
             </a:fld>
             <a:endParaRPr lang="en-US"/>
           </a:p>
@@ -2078,7 +2078,7 @@
           <a:p>
             <a:fld id="{2887AE02-B111-4481-B2BD-B82CAADB2540}" type="datetimeFigureOut">
               <a:rPr lang="en-US" smtClean="0"/>
-              <a:t>12/12/2024</a:t>
+              <a:t>2/27/2025</a:t>
             </a:fld>
             <a:endParaRPr lang="en-US"/>
           </a:p>
@@ -2389,7 +2389,7 @@
           <a:p>
             <a:fld id="{2887AE02-B111-4481-B2BD-B82CAADB2540}" type="datetimeFigureOut">
               <a:rPr lang="en-US" smtClean="0"/>
-              <a:t>12/12/2024</a:t>
+              <a:t>2/27/2025</a:t>
             </a:fld>
             <a:endParaRPr lang="en-US"/>
           </a:p>
@@ -2677,7 +2677,7 @@
           <a:p>
             <a:fld id="{2887AE02-B111-4481-B2BD-B82CAADB2540}" type="datetimeFigureOut">
               <a:rPr lang="en-US" smtClean="0"/>
-              <a:t>12/12/2024</a:t>
+              <a:t>2/27/2025</a:t>
             </a:fld>
             <a:endParaRPr lang="en-US"/>
           </a:p>
@@ -2918,7 +2918,7 @@
           <a:p>
             <a:fld id="{2887AE02-B111-4481-B2BD-B82CAADB2540}" type="datetimeFigureOut">
               <a:rPr lang="en-US" smtClean="0"/>
-              <a:t>12/12/2024</a:t>
+              <a:t>2/27/2025</a:t>
             </a:fld>
             <a:endParaRPr lang="en-US"/>
           </a:p>
@@ -4917,7 +4917,17 @@
               <a:rPr lang="en-US" sz="1200" dirty="0">
                 <a:effectLst/>
               </a:rPr>
-              <a:t>= Recommended, tested with tools.</a:t>
+              <a:t>= Recommended, </a:t>
+            </a:r>
+            <a:r>
+              <a:rPr lang="en-US" sz="1200" dirty="0"/>
+              <a:t>confirmed working</a:t>
+            </a:r>
+            <a:r>
+              <a:rPr lang="en-US" sz="1200" dirty="0">
+                <a:effectLst/>
+              </a:rPr>
+              <a:t> with tools.</a:t>
             </a:r>
           </a:p>
           <a:p>
@@ -4942,7 +4952,7 @@
             </a:r>
             <a:r>
               <a:rPr lang="en-US" sz="1200" dirty="0"/>
-              <a:t> = Supported, can use tools but may fail to take proper thought chains. May require multiple repeat queries to get a satisfactory answer,</a:t>
+              <a:t> = Partially supported, can use tools but may fail to take proper thought chains. May require multiple repeat queries to get a satisfactory answer.</a:t>
             </a:r>
           </a:p>
           <a:p>
@@ -5139,15 +5149,21 @@
               </a:spcBef>
             </a:pPr>
             <a:r>
-              <a:rPr lang="en-US" sz="1200" b="1" dirty="0">
+              <a:rPr lang="en-US" sz="1200" b="1">
                 <a:solidFill>
                   <a:srgbClr val="00B050"/>
                 </a:solidFill>
-                <a:effectLst/>
                 <a:latin typeface="Consolas" panose="020B0609020204030204" pitchFamily="49" charset="0"/>
               </a:rPr>
-              <a:t>azure-gpt-4o</a:t>
-            </a:r>
+              <a:t>azure-o3-mini</a:t>
+            </a:r>
+            <a:endParaRPr lang="en-US" sz="1200" b="1">
+              <a:solidFill>
+                <a:srgbClr val="00B050"/>
+              </a:solidFill>
+              <a:effectLst/>
+              <a:latin typeface="Consolas" panose="020B0609020204030204" pitchFamily="49" charset="0"/>
+            </a:endParaRPr>
           </a:p>
           <a:p>
             <a:pPr lvl="1">
@@ -5161,14 +5177,12 @@
             <a:r>
               <a:rPr lang="en-US" sz="1200" b="1" dirty="0">
                 <a:solidFill>
-                  <a:schemeClr val="accent4">
-                    <a:lumMod val="75000"/>
-                  </a:schemeClr>
+                  <a:srgbClr val="00B050"/>
                 </a:solidFill>
                 <a:effectLst/>
                 <a:latin typeface="Consolas" panose="020B0609020204030204" pitchFamily="49" charset="0"/>
               </a:rPr>
-              <a:t>azure-gpt-3.5-turbo (cannot handle large/complex queries)</a:t>
+              <a:t>azure-o1</a:t>
             </a:r>
           </a:p>
           <a:p>
@@ -5183,15 +5197,19 @@
             <a:r>
               <a:rPr lang="en-US" sz="1200" b="1" dirty="0">
                 <a:solidFill>
-                  <a:schemeClr val="accent4">
-                    <a:lumMod val="75000"/>
-                  </a:schemeClr>
-                </a:solidFill>
-                <a:effectLst/>
+                  <a:srgbClr val="00B050"/>
+                </a:solidFill>
                 <a:latin typeface="Consolas" panose="020B0609020204030204" pitchFamily="49" charset="0"/>
               </a:rPr>
-              <a:t>azure-gpt-4o-mini (may need large number of max iterations)</a:t>
-            </a:r>
+              <a:t>azure-o1-mini</a:t>
+            </a:r>
+            <a:endParaRPr lang="en-US" sz="1200" b="1" dirty="0">
+              <a:solidFill>
+                <a:srgbClr val="00B050"/>
+              </a:solidFill>
+              <a:effectLst/>
+              <a:latin typeface="Consolas" panose="020B0609020204030204" pitchFamily="49" charset="0"/>
+            </a:endParaRPr>
           </a:p>
           <a:p>
             <a:pPr lvl="1">
@@ -5210,7 +5228,7 @@
                 <a:effectLst/>
                 <a:latin typeface="Consolas" panose="020B0609020204030204" pitchFamily="49" charset="0"/>
               </a:rPr>
-              <a:t>azure-gpt-3.5-turbo-16k</a:t>
+              <a:t>azure-gpt-4o</a:t>
             </a:r>
           </a:p>
           <a:p>
@@ -5225,12 +5243,14 @@
             <a:r>
               <a:rPr lang="en-US" sz="1200" b="1" dirty="0">
                 <a:solidFill>
-                  <a:srgbClr val="00B050"/>
+                  <a:schemeClr val="accent4">
+                    <a:lumMod val="75000"/>
+                  </a:schemeClr>
                 </a:solidFill>
                 <a:effectLst/>
                 <a:latin typeface="Consolas" panose="020B0609020204030204" pitchFamily="49" charset="0"/>
               </a:rPr>
-              <a:t>azure-gpt-4-turbo-20240409</a:t>
+              <a:t>azure-gpt-4o-mini (may need large number of max iterations)</a:t>
             </a:r>
           </a:p>
           <a:p>
@@ -5251,6 +5271,68 @@
                 <a:latin typeface="Consolas" panose="020B0609020204030204" pitchFamily="49" charset="0"/>
               </a:rPr>
               <a:t>azure-gpt-4</a:t>
+            </a:r>
+          </a:p>
+          <a:p>
+            <a:pPr lvl="1">
+              <a:lnSpc>
+                <a:spcPct val="100000"/>
+              </a:lnSpc>
+              <a:spcBef>
+                <a:spcPts val="0"/>
+              </a:spcBef>
+            </a:pPr>
+            <a:r>
+              <a:rPr lang="en-US" sz="1200" b="1" dirty="0">
+                <a:solidFill>
+                  <a:srgbClr val="00B050"/>
+                </a:solidFill>
+                <a:effectLst/>
+                <a:latin typeface="Consolas" panose="020B0609020204030204" pitchFamily="49" charset="0"/>
+              </a:rPr>
+              <a:t>azure-gpt-4-turbo-20240409</a:t>
+            </a:r>
+          </a:p>
+          <a:p>
+            <a:pPr lvl="1">
+              <a:lnSpc>
+                <a:spcPct val="100000"/>
+              </a:lnSpc>
+              <a:spcBef>
+                <a:spcPts val="0"/>
+              </a:spcBef>
+            </a:pPr>
+            <a:r>
+              <a:rPr lang="en-US" sz="1200" b="1" dirty="0">
+                <a:solidFill>
+                  <a:schemeClr val="accent4">
+                    <a:lumMod val="75000"/>
+                  </a:schemeClr>
+                </a:solidFill>
+                <a:effectLst/>
+                <a:latin typeface="Consolas" panose="020B0609020204030204" pitchFamily="49" charset="0"/>
+              </a:rPr>
+              <a:t>azure-gpt-3.5-turbo (cannot handle large/complex queries)</a:t>
+            </a:r>
+          </a:p>
+          <a:p>
+            <a:pPr lvl="1">
+              <a:lnSpc>
+                <a:spcPct val="100000"/>
+              </a:lnSpc>
+              <a:spcBef>
+                <a:spcPts val="0"/>
+              </a:spcBef>
+            </a:pPr>
+            <a:r>
+              <a:rPr lang="en-US" sz="1200" b="1" dirty="0">
+                <a:solidFill>
+                  <a:srgbClr val="00B050"/>
+                </a:solidFill>
+                <a:effectLst/>
+                <a:latin typeface="Consolas" panose="020B0609020204030204" pitchFamily="49" charset="0"/>
+              </a:rPr>
+              <a:t>azure-gpt-3.5-turbo-16k</a:t>
             </a:r>
           </a:p>
           <a:p>

</xml_diff>

<commit_message>
Updates supported models list
</commit_message>
<xml_diff>
--- a/ToxPipe API Guide.pptx
+++ b/ToxPipe API Guide.pptx
@@ -268,7 +268,7 @@
           <a:p>
             <a:fld id="{2887AE02-B111-4481-B2BD-B82CAADB2540}" type="datetimeFigureOut">
               <a:rPr lang="en-US" smtClean="0"/>
-              <a:t>2/27/2025</a:t>
+              <a:t>5/14/2025</a:t>
             </a:fld>
             <a:endParaRPr lang="en-US"/>
           </a:p>
@@ -466,7 +466,7 @@
           <a:p>
             <a:fld id="{2887AE02-B111-4481-B2BD-B82CAADB2540}" type="datetimeFigureOut">
               <a:rPr lang="en-US" smtClean="0"/>
-              <a:t>2/27/2025</a:t>
+              <a:t>5/14/2025</a:t>
             </a:fld>
             <a:endParaRPr lang="en-US"/>
           </a:p>
@@ -674,7 +674,7 @@
           <a:p>
             <a:fld id="{2887AE02-B111-4481-B2BD-B82CAADB2540}" type="datetimeFigureOut">
               <a:rPr lang="en-US" smtClean="0"/>
-              <a:t>2/27/2025</a:t>
+              <a:t>5/14/2025</a:t>
             </a:fld>
             <a:endParaRPr lang="en-US"/>
           </a:p>
@@ -872,7 +872,7 @@
           <a:p>
             <a:fld id="{2887AE02-B111-4481-B2BD-B82CAADB2540}" type="datetimeFigureOut">
               <a:rPr lang="en-US" smtClean="0"/>
-              <a:t>2/27/2025</a:t>
+              <a:t>5/14/2025</a:t>
             </a:fld>
             <a:endParaRPr lang="en-US"/>
           </a:p>
@@ -1147,7 +1147,7 @@
           <a:p>
             <a:fld id="{2887AE02-B111-4481-B2BD-B82CAADB2540}" type="datetimeFigureOut">
               <a:rPr lang="en-US" smtClean="0"/>
-              <a:t>2/27/2025</a:t>
+              <a:t>5/14/2025</a:t>
             </a:fld>
             <a:endParaRPr lang="en-US"/>
           </a:p>
@@ -1412,7 +1412,7 @@
           <a:p>
             <a:fld id="{2887AE02-B111-4481-B2BD-B82CAADB2540}" type="datetimeFigureOut">
               <a:rPr lang="en-US" smtClean="0"/>
-              <a:t>2/27/2025</a:t>
+              <a:t>5/14/2025</a:t>
             </a:fld>
             <a:endParaRPr lang="en-US"/>
           </a:p>
@@ -1824,7 +1824,7 @@
           <a:p>
             <a:fld id="{2887AE02-B111-4481-B2BD-B82CAADB2540}" type="datetimeFigureOut">
               <a:rPr lang="en-US" smtClean="0"/>
-              <a:t>2/27/2025</a:t>
+              <a:t>5/14/2025</a:t>
             </a:fld>
             <a:endParaRPr lang="en-US"/>
           </a:p>
@@ -1965,7 +1965,7 @@
           <a:p>
             <a:fld id="{2887AE02-B111-4481-B2BD-B82CAADB2540}" type="datetimeFigureOut">
               <a:rPr lang="en-US" smtClean="0"/>
-              <a:t>2/27/2025</a:t>
+              <a:t>5/14/2025</a:t>
             </a:fld>
             <a:endParaRPr lang="en-US"/>
           </a:p>
@@ -2078,7 +2078,7 @@
           <a:p>
             <a:fld id="{2887AE02-B111-4481-B2BD-B82CAADB2540}" type="datetimeFigureOut">
               <a:rPr lang="en-US" smtClean="0"/>
-              <a:t>2/27/2025</a:t>
+              <a:t>5/14/2025</a:t>
             </a:fld>
             <a:endParaRPr lang="en-US"/>
           </a:p>
@@ -2389,7 +2389,7 @@
           <a:p>
             <a:fld id="{2887AE02-B111-4481-B2BD-B82CAADB2540}" type="datetimeFigureOut">
               <a:rPr lang="en-US" smtClean="0"/>
-              <a:t>2/27/2025</a:t>
+              <a:t>5/14/2025</a:t>
             </a:fld>
             <a:endParaRPr lang="en-US"/>
           </a:p>
@@ -2677,7 +2677,7 @@
           <a:p>
             <a:fld id="{2887AE02-B111-4481-B2BD-B82CAADB2540}" type="datetimeFigureOut">
               <a:rPr lang="en-US" smtClean="0"/>
-              <a:t>2/27/2025</a:t>
+              <a:t>5/14/2025</a:t>
             </a:fld>
             <a:endParaRPr lang="en-US"/>
           </a:p>
@@ -2918,7 +2918,7 @@
           <a:p>
             <a:fld id="{2887AE02-B111-4481-B2BD-B82CAADB2540}" type="datetimeFigureOut">
               <a:rPr lang="en-US" smtClean="0"/>
-              <a:t>2/27/2025</a:t>
+              <a:t>5/14/2025</a:t>
             </a:fld>
             <a:endParaRPr lang="en-US"/>
           </a:p>
@@ -3390,8 +3390,21 @@
           <a:p>
             <a:r>
               <a:rPr lang="en-US" dirty="0"/>
-              <a:t>Last Updated: Dec. 12, 2024</a:t>
-            </a:r>
+              <a:t>Last Updated</a:t>
+            </a:r>
+            <a:r>
+              <a:rPr lang="en-US"/>
+              <a:t>: May </a:t>
+            </a:r>
+            <a:r>
+              <a:rPr lang="en-US" dirty="0"/>
+              <a:t>14</a:t>
+            </a:r>
+            <a:r>
+              <a:rPr lang="en-US"/>
+              <a:t>, 2025</a:t>
+            </a:r>
+            <a:endParaRPr lang="en-US" dirty="0"/>
           </a:p>
         </p:txBody>
       </p:sp>
@@ -4889,106 +4902,6 @@
           </a:bodyPr>
           <a:lstStyle/>
           <a:p>
-            <a:pPr marL="0" indent="0">
-              <a:lnSpc>
-                <a:spcPct val="100000"/>
-              </a:lnSpc>
-              <a:spcBef>
-                <a:spcPts val="0"/>
-              </a:spcBef>
-              <a:buNone/>
-            </a:pPr>
-            <a:r>
-              <a:rPr lang="en-US" sz="1200" b="1" dirty="0">
-                <a:solidFill>
-                  <a:srgbClr val="00B050"/>
-                </a:solidFill>
-                <a:effectLst/>
-              </a:rPr>
-              <a:t>Green</a:t>
-            </a:r>
-            <a:r>
-              <a:rPr lang="en-US" sz="1200" b="1" dirty="0">
-                <a:effectLst/>
-              </a:rPr>
-              <a:t> </a:t>
-            </a:r>
-            <a:r>
-              <a:rPr lang="en-US" sz="1200" dirty="0">
-                <a:effectLst/>
-              </a:rPr>
-              <a:t>= Recommended, </a:t>
-            </a:r>
-            <a:r>
-              <a:rPr lang="en-US" sz="1200" dirty="0"/>
-              <a:t>confirmed working</a:t>
-            </a:r>
-            <a:r>
-              <a:rPr lang="en-US" sz="1200" dirty="0">
-                <a:effectLst/>
-              </a:rPr>
-              <a:t> with tools.</a:t>
-            </a:r>
-          </a:p>
-          <a:p>
-            <a:pPr marL="0" indent="0">
-              <a:lnSpc>
-                <a:spcPct val="100000"/>
-              </a:lnSpc>
-              <a:spcBef>
-                <a:spcPts val="0"/>
-              </a:spcBef>
-              <a:buNone/>
-            </a:pPr>
-            <a:r>
-              <a:rPr lang="en-US" sz="1200" b="1" dirty="0">
-                <a:solidFill>
-                  <a:schemeClr val="accent4">
-                    <a:lumMod val="75000"/>
-                  </a:schemeClr>
-                </a:solidFill>
-              </a:rPr>
-              <a:t>Yellow</a:t>
-            </a:r>
-            <a:r>
-              <a:rPr lang="en-US" sz="1200" dirty="0"/>
-              <a:t> = Partially supported, can use tools but may fail to take proper thought chains. May require multiple repeat queries to get a satisfactory answer.</a:t>
-            </a:r>
-          </a:p>
-          <a:p>
-            <a:pPr marL="0" indent="0">
-              <a:lnSpc>
-                <a:spcPct val="100000"/>
-              </a:lnSpc>
-              <a:spcBef>
-                <a:spcPts val="0"/>
-              </a:spcBef>
-              <a:buNone/>
-            </a:pPr>
-            <a:r>
-              <a:rPr lang="en-US" sz="1200" b="1" dirty="0">
-                <a:solidFill>
-                  <a:srgbClr val="C00000"/>
-                </a:solidFill>
-                <a:effectLst/>
-              </a:rPr>
-              <a:t>Red</a:t>
-            </a:r>
-            <a:r>
-              <a:rPr lang="en-US" sz="1200" dirty="0">
-                <a:effectLst/>
-              </a:rPr>
-              <a:t> = Unsupported, </a:t>
-            </a:r>
-            <a:r>
-              <a:rPr lang="en-US" sz="1200" dirty="0"/>
-              <a:t>may be used but will not properly use tools. These models either hallucinate or rely on training data.</a:t>
-            </a:r>
-            <a:endParaRPr lang="en-US" sz="1200" dirty="0">
-              <a:effectLst/>
-            </a:endParaRPr>
-          </a:p>
-          <a:p>
             <a:pPr>
               <a:lnSpc>
                 <a:spcPct val="100000"/>
@@ -4998,92 +4911,21 @@
               </a:spcBef>
             </a:pPr>
             <a:r>
-              <a:rPr lang="en-US" sz="1200" b="1" dirty="0">
-                <a:effectLst/>
-              </a:rPr>
-              <a:t>Anthropic</a:t>
-            </a:r>
-            <a:endParaRPr lang="en-US" sz="1200" b="1" dirty="0"/>
-          </a:p>
-          <a:p>
-            <a:pPr lvl="1">
-              <a:lnSpc>
-                <a:spcPct val="100000"/>
-              </a:lnSpc>
-              <a:spcBef>
-                <a:spcPts val="0"/>
-              </a:spcBef>
-            </a:pPr>
-            <a:r>
-              <a:rPr lang="en-US" sz="1200" b="1" dirty="0">
+              <a:rPr lang="en-US" sz="1600" b="1" dirty="0">
                 <a:solidFill>
                   <a:srgbClr val="00B050"/>
                 </a:solidFill>
-                <a:effectLst/>
                 <a:latin typeface="Consolas" panose="020B0609020204030204" pitchFamily="49" charset="0"/>
               </a:rPr>
-              <a:t>claude-3-5-sonnet</a:t>
-            </a:r>
-          </a:p>
-          <a:p>
-            <a:pPr lvl="1">
-              <a:lnSpc>
-                <a:spcPct val="100000"/>
-              </a:lnSpc>
-              <a:spcBef>
-                <a:spcPts val="0"/>
-              </a:spcBef>
-            </a:pPr>
-            <a:r>
-              <a:rPr lang="en-US" sz="1200" b="1" dirty="0">
-                <a:solidFill>
-                  <a:srgbClr val="C00000"/>
-                </a:solidFill>
-                <a:effectLst/>
-                <a:latin typeface="Consolas" panose="020B0609020204030204" pitchFamily="49" charset="0"/>
-              </a:rPr>
-              <a:t>claude-3-sonnet</a:t>
-            </a:r>
-          </a:p>
-          <a:p>
-            <a:pPr lvl="1">
-              <a:lnSpc>
-                <a:spcPct val="100000"/>
-              </a:lnSpc>
-              <a:spcBef>
-                <a:spcPts val="0"/>
-              </a:spcBef>
-            </a:pPr>
-            <a:r>
-              <a:rPr lang="en-US" sz="1200" b="1" dirty="0">
-                <a:solidFill>
-                  <a:srgbClr val="00B050"/>
-                </a:solidFill>
-                <a:effectLst/>
-                <a:latin typeface="Consolas" panose="020B0609020204030204" pitchFamily="49" charset="0"/>
-              </a:rPr>
-              <a:t>claude-3-haiku</a:t>
-            </a:r>
-          </a:p>
-          <a:p>
-            <a:pPr lvl="1">
-              <a:lnSpc>
-                <a:spcPct val="100000"/>
-              </a:lnSpc>
-              <a:spcBef>
-                <a:spcPts val="0"/>
-              </a:spcBef>
-            </a:pPr>
-            <a:r>
-              <a:rPr lang="en-US" sz="1200" b="1" dirty="0">
-                <a:solidFill>
-                  <a:srgbClr val="00B050"/>
-                </a:solidFill>
-                <a:effectLst/>
-                <a:latin typeface="Consolas" panose="020B0609020204030204" pitchFamily="49" charset="0"/>
-              </a:rPr>
-              <a:t>claude-3-opus</a:t>
-            </a:r>
+              <a:t>azure-o3-mini</a:t>
+            </a:r>
+            <a:endParaRPr lang="en-US" sz="1600" b="1" dirty="0">
+              <a:solidFill>
+                <a:srgbClr val="00B050"/>
+              </a:solidFill>
+              <a:effectLst/>
+              <a:latin typeface="Consolas" panose="020B0609020204030204" pitchFamily="49" charset="0"/>
+            </a:endParaRPr>
           </a:p>
           <a:p>
             <a:pPr>
@@ -5095,32 +4937,14 @@
               </a:spcBef>
             </a:pPr>
             <a:r>
-              <a:rPr lang="en-US" sz="1200" b="1" dirty="0">
-                <a:effectLst/>
-              </a:rPr>
-              <a:t>Meta</a:t>
-            </a:r>
-          </a:p>
-          <a:p>
-            <a:pPr lvl="1">
-              <a:lnSpc>
-                <a:spcPct val="100000"/>
-              </a:lnSpc>
-              <a:spcBef>
-                <a:spcPts val="0"/>
-              </a:spcBef>
-            </a:pPr>
-            <a:r>
-              <a:rPr lang="en-US" sz="1200" b="1" dirty="0">
+              <a:rPr lang="en-US" sz="1600" b="1" dirty="0">
                 <a:solidFill>
-                  <a:schemeClr val="accent4">
-                    <a:lumMod val="75000"/>
-                  </a:schemeClr>
+                  <a:srgbClr val="00B050"/>
                 </a:solidFill>
                 <a:effectLst/>
                 <a:latin typeface="Consolas" panose="020B0609020204030204" pitchFamily="49" charset="0"/>
               </a:rPr>
-              <a:t>llama3-1-70b</a:t>
+              <a:t>azure-o3</a:t>
             </a:r>
           </a:p>
           <a:p>
@@ -5133,398 +4957,15 @@
               </a:spcBef>
             </a:pPr>
             <a:r>
-              <a:rPr lang="en-US" sz="1200" b="1" dirty="0">
-                <a:effectLst/>
-              </a:rPr>
-              <a:t>Azure OpenAI</a:t>
-            </a:r>
-          </a:p>
-          <a:p>
-            <a:pPr lvl="1">
-              <a:lnSpc>
-                <a:spcPct val="100000"/>
-              </a:lnSpc>
-              <a:spcBef>
-                <a:spcPts val="0"/>
-              </a:spcBef>
-            </a:pPr>
-            <a:r>
-              <a:rPr lang="en-US" sz="1200" b="1">
-                <a:solidFill>
-                  <a:srgbClr val="00B050"/>
-                </a:solidFill>
-                <a:latin typeface="Consolas" panose="020B0609020204030204" pitchFamily="49" charset="0"/>
-              </a:rPr>
-              <a:t>azure-o3-mini</a:t>
-            </a:r>
-            <a:endParaRPr lang="en-US" sz="1200" b="1">
-              <a:solidFill>
-                <a:srgbClr val="00B050"/>
-              </a:solidFill>
-              <a:effectLst/>
-              <a:latin typeface="Consolas" panose="020B0609020204030204" pitchFamily="49" charset="0"/>
-            </a:endParaRPr>
-          </a:p>
-          <a:p>
-            <a:pPr lvl="1">
-              <a:lnSpc>
-                <a:spcPct val="100000"/>
-              </a:lnSpc>
-              <a:spcBef>
-                <a:spcPts val="0"/>
-              </a:spcBef>
-            </a:pPr>
-            <a:r>
-              <a:rPr lang="en-US" sz="1200" b="1" dirty="0">
+              <a:rPr lang="en-US" sz="1600" b="1" dirty="0">
                 <a:solidFill>
                   <a:srgbClr val="00B050"/>
                 </a:solidFill>
                 <a:effectLst/>
                 <a:latin typeface="Consolas" panose="020B0609020204030204" pitchFamily="49" charset="0"/>
               </a:rPr>
-              <a:t>azure-o1</a:t>
-            </a:r>
-          </a:p>
-          <a:p>
-            <a:pPr lvl="1">
-              <a:lnSpc>
-                <a:spcPct val="100000"/>
-              </a:lnSpc>
-              <a:spcBef>
-                <a:spcPts val="0"/>
-              </a:spcBef>
-            </a:pPr>
-            <a:r>
-              <a:rPr lang="en-US" sz="1200" b="1" dirty="0">
-                <a:solidFill>
-                  <a:srgbClr val="00B050"/>
-                </a:solidFill>
-                <a:latin typeface="Consolas" panose="020B0609020204030204" pitchFamily="49" charset="0"/>
-              </a:rPr>
-              <a:t>azure-o1-mini</a:t>
-            </a:r>
-            <a:endParaRPr lang="en-US" sz="1200" b="1" dirty="0">
-              <a:solidFill>
-                <a:srgbClr val="00B050"/>
-              </a:solidFill>
-              <a:effectLst/>
-              <a:latin typeface="Consolas" panose="020B0609020204030204" pitchFamily="49" charset="0"/>
-            </a:endParaRPr>
-          </a:p>
-          <a:p>
-            <a:pPr lvl="1">
-              <a:lnSpc>
-                <a:spcPct val="100000"/>
-              </a:lnSpc>
-              <a:spcBef>
-                <a:spcPts val="0"/>
-              </a:spcBef>
-            </a:pPr>
-            <a:r>
-              <a:rPr lang="en-US" sz="1200" b="1" dirty="0">
-                <a:solidFill>
-                  <a:srgbClr val="00B050"/>
-                </a:solidFill>
-                <a:effectLst/>
-                <a:latin typeface="Consolas" panose="020B0609020204030204" pitchFamily="49" charset="0"/>
-              </a:rPr>
               <a:t>azure-gpt-4o</a:t>
             </a:r>
-          </a:p>
-          <a:p>
-            <a:pPr lvl="1">
-              <a:lnSpc>
-                <a:spcPct val="100000"/>
-              </a:lnSpc>
-              <a:spcBef>
-                <a:spcPts val="0"/>
-              </a:spcBef>
-            </a:pPr>
-            <a:r>
-              <a:rPr lang="en-US" sz="1200" b="1" dirty="0">
-                <a:solidFill>
-                  <a:schemeClr val="accent4">
-                    <a:lumMod val="75000"/>
-                  </a:schemeClr>
-                </a:solidFill>
-                <a:effectLst/>
-                <a:latin typeface="Consolas" panose="020B0609020204030204" pitchFamily="49" charset="0"/>
-              </a:rPr>
-              <a:t>azure-gpt-4o-mini (may need large number of max iterations)</a:t>
-            </a:r>
-          </a:p>
-          <a:p>
-            <a:pPr lvl="1">
-              <a:lnSpc>
-                <a:spcPct val="100000"/>
-              </a:lnSpc>
-              <a:spcBef>
-                <a:spcPts val="0"/>
-              </a:spcBef>
-            </a:pPr>
-            <a:r>
-              <a:rPr lang="en-US" sz="1200" b="1" dirty="0">
-                <a:solidFill>
-                  <a:srgbClr val="00B050"/>
-                </a:solidFill>
-                <a:effectLst/>
-                <a:latin typeface="Consolas" panose="020B0609020204030204" pitchFamily="49" charset="0"/>
-              </a:rPr>
-              <a:t>azure-gpt-4</a:t>
-            </a:r>
-          </a:p>
-          <a:p>
-            <a:pPr lvl="1">
-              <a:lnSpc>
-                <a:spcPct val="100000"/>
-              </a:lnSpc>
-              <a:spcBef>
-                <a:spcPts val="0"/>
-              </a:spcBef>
-            </a:pPr>
-            <a:r>
-              <a:rPr lang="en-US" sz="1200" b="1" dirty="0">
-                <a:solidFill>
-                  <a:srgbClr val="00B050"/>
-                </a:solidFill>
-                <a:effectLst/>
-                <a:latin typeface="Consolas" panose="020B0609020204030204" pitchFamily="49" charset="0"/>
-              </a:rPr>
-              <a:t>azure-gpt-4-turbo-20240409</a:t>
-            </a:r>
-          </a:p>
-          <a:p>
-            <a:pPr lvl="1">
-              <a:lnSpc>
-                <a:spcPct val="100000"/>
-              </a:lnSpc>
-              <a:spcBef>
-                <a:spcPts val="0"/>
-              </a:spcBef>
-            </a:pPr>
-            <a:r>
-              <a:rPr lang="en-US" sz="1200" b="1" dirty="0">
-                <a:solidFill>
-                  <a:schemeClr val="accent4">
-                    <a:lumMod val="75000"/>
-                  </a:schemeClr>
-                </a:solidFill>
-                <a:effectLst/>
-                <a:latin typeface="Consolas" panose="020B0609020204030204" pitchFamily="49" charset="0"/>
-              </a:rPr>
-              <a:t>azure-gpt-3.5-turbo (cannot handle large/complex queries)</a:t>
-            </a:r>
-          </a:p>
-          <a:p>
-            <a:pPr lvl="1">
-              <a:lnSpc>
-                <a:spcPct val="100000"/>
-              </a:lnSpc>
-              <a:spcBef>
-                <a:spcPts val="0"/>
-              </a:spcBef>
-            </a:pPr>
-            <a:r>
-              <a:rPr lang="en-US" sz="1200" b="1" dirty="0">
-                <a:solidFill>
-                  <a:srgbClr val="00B050"/>
-                </a:solidFill>
-                <a:effectLst/>
-                <a:latin typeface="Consolas" panose="020B0609020204030204" pitchFamily="49" charset="0"/>
-              </a:rPr>
-              <a:t>azure-gpt-3.5-turbo-16k</a:t>
-            </a:r>
-          </a:p>
-          <a:p>
-            <a:pPr>
-              <a:lnSpc>
-                <a:spcPct val="100000"/>
-              </a:lnSpc>
-              <a:spcBef>
-                <a:spcPts val="0"/>
-              </a:spcBef>
-            </a:pPr>
-            <a:r>
-              <a:rPr lang="en-US" sz="1200" b="1" dirty="0" err="1">
-                <a:effectLst/>
-              </a:rPr>
-              <a:t>MistralAI</a:t>
-            </a:r>
-            <a:endParaRPr lang="en-US" sz="1200" b="1" dirty="0">
-              <a:effectLst/>
-            </a:endParaRPr>
-          </a:p>
-          <a:p>
-            <a:pPr lvl="1">
-              <a:lnSpc>
-                <a:spcPct val="100000"/>
-              </a:lnSpc>
-              <a:spcBef>
-                <a:spcPts val="0"/>
-              </a:spcBef>
-            </a:pPr>
-            <a:r>
-              <a:rPr lang="en-US" sz="1200" b="1" dirty="0">
-                <a:solidFill>
-                  <a:schemeClr val="accent4">
-                    <a:lumMod val="75000"/>
-                  </a:schemeClr>
-                </a:solidFill>
-                <a:effectLst/>
-                <a:latin typeface="Consolas" panose="020B0609020204030204" pitchFamily="49" charset="0"/>
-              </a:rPr>
-              <a:t>mistral-large-2</a:t>
-            </a:r>
-          </a:p>
-          <a:p>
-            <a:pPr lvl="1">
-              <a:lnSpc>
-                <a:spcPct val="100000"/>
-              </a:lnSpc>
-              <a:spcBef>
-                <a:spcPts val="0"/>
-              </a:spcBef>
-            </a:pPr>
-            <a:r>
-              <a:rPr lang="en-US" sz="1200" b="1" dirty="0">
-                <a:solidFill>
-                  <a:srgbClr val="C00000"/>
-                </a:solidFill>
-                <a:effectLst/>
-                <a:latin typeface="Consolas" panose="020B0609020204030204" pitchFamily="49" charset="0"/>
-              </a:rPr>
-              <a:t>mistral-large</a:t>
-            </a:r>
-          </a:p>
-          <a:p>
-            <a:pPr lvl="1">
-              <a:lnSpc>
-                <a:spcPct val="100000"/>
-              </a:lnSpc>
-              <a:spcBef>
-                <a:spcPts val="0"/>
-              </a:spcBef>
-            </a:pPr>
-            <a:r>
-              <a:rPr lang="en-US" sz="1200" b="1" dirty="0">
-                <a:solidFill>
-                  <a:srgbClr val="C00000"/>
-                </a:solidFill>
-                <a:effectLst/>
-                <a:latin typeface="Consolas" panose="020B0609020204030204" pitchFamily="49" charset="0"/>
-              </a:rPr>
-              <a:t>mistral-7b-instruct</a:t>
-            </a:r>
-          </a:p>
-          <a:p>
-            <a:pPr lvl="1">
-              <a:lnSpc>
-                <a:spcPct val="100000"/>
-              </a:lnSpc>
-              <a:spcBef>
-                <a:spcPts val="0"/>
-              </a:spcBef>
-            </a:pPr>
-            <a:r>
-              <a:rPr lang="en-US" sz="1200" b="1" dirty="0">
-                <a:solidFill>
-                  <a:schemeClr val="accent4">
-                    <a:lumMod val="75000"/>
-                  </a:schemeClr>
-                </a:solidFill>
-                <a:effectLst/>
-                <a:latin typeface="Consolas" panose="020B0609020204030204" pitchFamily="49" charset="0"/>
-              </a:rPr>
-              <a:t>mixtral-8x7b-instruct</a:t>
-            </a:r>
-          </a:p>
-          <a:p>
-            <a:pPr>
-              <a:lnSpc>
-                <a:spcPct val="100000"/>
-              </a:lnSpc>
-              <a:spcBef>
-                <a:spcPts val="0"/>
-              </a:spcBef>
-            </a:pPr>
-            <a:r>
-              <a:rPr lang="en-US" sz="1200" b="1" dirty="0">
-                <a:effectLst/>
-              </a:rPr>
-              <a:t>Amazon</a:t>
-            </a:r>
-          </a:p>
-          <a:p>
-            <a:pPr lvl="1">
-              <a:lnSpc>
-                <a:spcPct val="100000"/>
-              </a:lnSpc>
-              <a:spcBef>
-                <a:spcPts val="0"/>
-              </a:spcBef>
-            </a:pPr>
-            <a:r>
-              <a:rPr lang="en-US" sz="1200" b="1" dirty="0">
-                <a:solidFill>
-                  <a:srgbClr val="C00000"/>
-                </a:solidFill>
-                <a:effectLst/>
-                <a:latin typeface="Consolas" panose="020B0609020204030204" pitchFamily="49" charset="0"/>
-              </a:rPr>
-              <a:t>amazon-titan-text-premier</a:t>
-            </a:r>
-          </a:p>
-          <a:p>
-            <a:pPr>
-              <a:lnSpc>
-                <a:spcPct val="100000"/>
-              </a:lnSpc>
-              <a:spcBef>
-                <a:spcPts val="0"/>
-              </a:spcBef>
-            </a:pPr>
-            <a:r>
-              <a:rPr lang="en-US" sz="1200" b="1" dirty="0">
-                <a:effectLst/>
-              </a:rPr>
-              <a:t>Cohere</a:t>
-            </a:r>
-          </a:p>
-          <a:p>
-            <a:pPr lvl="1">
-              <a:lnSpc>
-                <a:spcPct val="100000"/>
-              </a:lnSpc>
-              <a:spcBef>
-                <a:spcPts val="0"/>
-              </a:spcBef>
-            </a:pPr>
-            <a:r>
-              <a:rPr lang="en-US" sz="1200" b="1" dirty="0">
-                <a:solidFill>
-                  <a:srgbClr val="C00000"/>
-                </a:solidFill>
-                <a:effectLst/>
-                <a:latin typeface="Consolas" panose="020B0609020204030204" pitchFamily="49" charset="0"/>
-              </a:rPr>
-              <a:t>cohere-command-r-plus</a:t>
-            </a:r>
-            <a:br>
-              <a:rPr lang="en-US" sz="1200" b="0" dirty="0">
-                <a:solidFill>
-                  <a:srgbClr val="C00000"/>
-                </a:solidFill>
-                <a:effectLst/>
-                <a:latin typeface="Consolas" panose="020B0609020204030204" pitchFamily="49" charset="0"/>
-              </a:rPr>
-            </a:br>
-            <a:endParaRPr lang="en-US" sz="1200" b="0" dirty="0">
-              <a:solidFill>
-                <a:srgbClr val="C00000"/>
-              </a:solidFill>
-              <a:effectLst/>
-              <a:latin typeface="Consolas" panose="020B0609020204030204" pitchFamily="49" charset="0"/>
-            </a:endParaRPr>
           </a:p>
           <a:p>
             <a:pPr>

</xml_diff>